<commit_message>
Update presentation with accurate current state and water focus
Changes:
- Footer: Manuel Ott · Hofer Lab · 2025-11-19
- Subtitle: Changed to "ML-accelerated IR spectroscopy"
- Focus on harmonic frequency analysis (current work)
- Water (H₂O) as primary benchmark molecule
- Removed geometry_based calculator (doesn't exist)
- Kept xTB calculator (is used as fallback)
- Updated workflow to reflect 4-phase pipeline
- Updated dipole calculators to show actual fallback chain
- Updated results slides to focus on water benchmark
- Slide 8: Changed from overtones to calculator combinations
- Slide 9: Updated to show actual CLI workflow
- Slide 10: Updated status and next steps
</commit_message>
<xml_diff>
--- a/presentation/mace_gaussian_presentation.pptx
+++ b/presentation/mace_gaussian_presentation.pptx
@@ -3178,7 +3178,7 @@
               </a:defRPr>
             </a:pPr>
             <a:r>
-              <a:t>// ML-accelerated anharmonic spectroscopy</a:t>
+              <a:t>// ML-accelerated IR spectroscopy</a:t>
             </a:r>
           </a:p>
         </p:txBody>
@@ -3214,7 +3214,7 @@
               </a:defRPr>
             </a:pPr>
             <a:r>
-              <a:t>Your Name · Research Group · 2025-11-15</a:t>
+              <a:t>Manuel Ott · Hofer Lab · 2025-11-19</a:t>
             </a:r>
           </a:p>
         </p:txBody>
@@ -3276,7 +3276,7 @@
               </a:defRPr>
             </a:pPr>
             <a:r>
-              <a:t>$ ./run_analysis.py water</a:t>
+              <a:t>$ python cli.py run water.xyz</a:t>
             </a:r>
           </a:p>
         </p:txBody>
@@ -3315,193 +3315,187 @@
               </a:defRPr>
             </a:pPr>
             <a:r>
-              <a:t># End-to-End Workflow</a:t>
-            </a:r>
-          </a:p>
-          <a:p>
-            <a:pPr>
-              <a:spcAft>
-                <a:spcPts val="600"/>
-              </a:spcAft>
-              <a:defRPr sz="1400">
-                <a:solidFill>
-                  <a:srgbClr val="C9D1D9"/>
-                </a:solidFill>
-                <a:latin typeface="Consolas"/>
-              </a:defRPr>
-            </a:pPr>
-          </a:p>
-          <a:p>
-            <a:pPr>
-              <a:spcAft>
-                <a:spcPts val="600"/>
-              </a:spcAft>
-              <a:defRPr sz="1400">
-                <a:solidFill>
-                  <a:srgbClr val="C9D1D9"/>
-                </a:solidFill>
-                <a:latin typeface="Consolas"/>
-              </a:defRPr>
-            </a:pPr>
-            <a:r>
-              <a:t>  1. Geometry optimization (MACE)</a:t>
-            </a:r>
-          </a:p>
-          <a:p>
-            <a:pPr>
-              <a:spcAft>
-                <a:spcPts val="600"/>
-              </a:spcAft>
-              <a:defRPr sz="1400">
-                <a:solidFill>
-                  <a:srgbClr val="C9D1D9"/>
-                </a:solidFill>
-                <a:latin typeface="Consolas"/>
-              </a:defRPr>
-            </a:pPr>
-            <a:r>
-              <a:t>  2. Frequency calculation (Gaussian + ML)</a:t>
-            </a:r>
-          </a:p>
-          <a:p>
-            <a:pPr>
-              <a:spcAft>
-                <a:spcPts val="600"/>
-              </a:spcAft>
-              <a:defRPr sz="1400">
-                <a:solidFill>
-                  <a:srgbClr val="C9D1D9"/>
-                </a:solidFill>
-                <a:latin typeface="Consolas"/>
-              </a:defRPr>
-            </a:pPr>
-            <a:r>
-              <a:t>  3. Anharmonic VPT2 (Gaussian)</a:t>
-            </a:r>
-          </a:p>
-          <a:p>
-            <a:pPr>
-              <a:spcAft>
-                <a:spcPts val="600"/>
-              </a:spcAft>
-              <a:defRPr sz="1400">
-                <a:solidFill>
-                  <a:srgbClr val="C9D1D9"/>
-                </a:solidFill>
-                <a:latin typeface="Consolas"/>
-              </a:defRPr>
-            </a:pPr>
-            <a:r>
-              <a:t>  4. Parse results (JSON)</a:t>
-            </a:r>
-          </a:p>
-          <a:p>
-            <a:pPr>
-              <a:spcAft>
-                <a:spcPts val="600"/>
-              </a:spcAft>
-              <a:defRPr sz="1400">
-                <a:solidFill>
-                  <a:srgbClr val="C9D1D9"/>
-                </a:solidFill>
-                <a:latin typeface="Consolas"/>
-              </a:defRPr>
-            </a:pPr>
-            <a:r>
-              <a:t>  5. Statistical analysis</a:t>
-            </a:r>
-          </a:p>
-          <a:p>
-            <a:pPr>
-              <a:spcAft>
-                <a:spcPts val="600"/>
-              </a:spcAft>
-              <a:defRPr sz="1400">
-                <a:solidFill>
-                  <a:srgbClr val="C9D1D9"/>
-                </a:solidFill>
-                <a:latin typeface="Consolas"/>
-              </a:defRPr>
-            </a:pPr>
-            <a:r>
-              <a:t>  6. HTML report generation</a:t>
-            </a:r>
-          </a:p>
-          <a:p>
-            <a:pPr>
-              <a:spcAft>
-                <a:spcPts val="600"/>
-              </a:spcAft>
-              <a:defRPr sz="1400">
-                <a:solidFill>
-                  <a:srgbClr val="C9D1D9"/>
-                </a:solidFill>
-                <a:latin typeface="Consolas"/>
-              </a:defRPr>
-            </a:pPr>
-          </a:p>
-          <a:p>
-            <a:pPr>
-              <a:spcAft>
-                <a:spcPts val="600"/>
-              </a:spcAft>
-              <a:defRPr sz="1400">
-                <a:solidFill>
-                  <a:srgbClr val="58A6FF"/>
-                </a:solidFill>
-                <a:latin typeface="Consolas"/>
-              </a:defRPr>
-            </a:pPr>
-            <a:r>
-              <a:t># Automation</a:t>
-            </a:r>
-          </a:p>
-          <a:p>
-            <a:pPr>
-              <a:spcAft>
-                <a:spcPts val="600"/>
-              </a:spcAft>
-              <a:defRPr sz="1400">
-                <a:solidFill>
-                  <a:srgbClr val="C9D1D9"/>
-                </a:solidFill>
-                <a:latin typeface="Consolas"/>
-              </a:defRPr>
-            </a:pPr>
-            <a:r>
-              <a:t>  → Hierarchical directory structure</a:t>
-            </a:r>
-          </a:p>
-          <a:p>
-            <a:pPr>
-              <a:spcAft>
-                <a:spcPts val="600"/>
-              </a:spcAft>
-              <a:defRPr sz="1400">
-                <a:solidFill>
-                  <a:srgbClr val="C9D1D9"/>
-                </a:solidFill>
-                <a:latin typeface="Consolas"/>
-              </a:defRPr>
-            </a:pPr>
-            <a:r>
-              <a:t>  → Automatic DFT baseline detection</a:t>
-            </a:r>
-          </a:p>
-          <a:p>
-            <a:pPr>
-              <a:spcAft>
-                <a:spcPts val="600"/>
-              </a:spcAft>
-              <a:defRPr sz="1400">
-                <a:solidFill>
-                  <a:srgbClr val="C9D1D9"/>
-                </a:solidFill>
-                <a:latin typeface="Consolas"/>
-              </a:defRPr>
-            </a:pPr>
-            <a:r>
-              <a:t>  → Publication-ready visualizations</a:t>
+              <a:t># 4-Phase Pipeline</a:t>
+            </a:r>
+          </a:p>
+          <a:p>
+            <a:pPr>
+              <a:spcAft>
+                <a:spcPts val="600"/>
+              </a:spcAft>
+              <a:defRPr sz="1400">
+                <a:solidFill>
+                  <a:srgbClr val="C9D1D9"/>
+                </a:solidFill>
+                <a:latin typeface="Consolas"/>
+              </a:defRPr>
+            </a:pPr>
+          </a:p>
+          <a:p>
+            <a:pPr>
+              <a:spcAft>
+                <a:spcPts val="600"/>
+              </a:spcAft>
+              <a:defRPr sz="1400">
+                <a:solidFill>
+                  <a:srgbClr val="C9D1D9"/>
+                </a:solidFill>
+                <a:latin typeface="Consolas"/>
+              </a:defRPr>
+            </a:pPr>
+            <a:r>
+              <a:t>  Phase 1: Geometry optimization</a:t>
+            </a:r>
+          </a:p>
+          <a:p>
+            <a:pPr>
+              <a:spcAft>
+                <a:spcPts val="600"/>
+              </a:spcAft>
+              <a:defRPr sz="1400">
+                <a:solidFill>
+                  <a:srgbClr val="C9D1D9"/>
+                </a:solidFill>
+                <a:latin typeface="Consolas"/>
+              </a:defRPr>
+            </a:pPr>
+            <a:r>
+              <a:t>    → MACE-OMOL calculator</a:t>
+            </a:r>
+          </a:p>
+          <a:p>
+            <a:pPr>
+              <a:spcAft>
+                <a:spcPts val="600"/>
+              </a:spcAft>
+              <a:defRPr sz="1400">
+                <a:solidFill>
+                  <a:srgbClr val="C9D1D9"/>
+                </a:solidFill>
+                <a:latin typeface="Consolas"/>
+              </a:defRPr>
+            </a:pPr>
+          </a:p>
+          <a:p>
+            <a:pPr>
+              <a:spcAft>
+                <a:spcPts val="600"/>
+              </a:spcAft>
+              <a:defRPr sz="1400">
+                <a:solidFill>
+                  <a:srgbClr val="C9D1D9"/>
+                </a:solidFill>
+                <a:latin typeface="Consolas"/>
+              </a:defRPr>
+            </a:pPr>
+            <a:r>
+              <a:t>  Phase 2: DFT baseline</a:t>
+            </a:r>
+          </a:p>
+          <a:p>
+            <a:pPr>
+              <a:spcAft>
+                <a:spcPts val="600"/>
+              </a:spcAft>
+              <a:defRPr sz="1400">
+                <a:solidFill>
+                  <a:srgbClr val="C9D1D9"/>
+                </a:solidFill>
+                <a:latin typeface="Consolas"/>
+              </a:defRPr>
+            </a:pPr>
+            <a:r>
+              <a:t>    → B3LYP/6-31G(d,p) frequencies</a:t>
+            </a:r>
+          </a:p>
+          <a:p>
+            <a:pPr>
+              <a:spcAft>
+                <a:spcPts val="600"/>
+              </a:spcAft>
+              <a:defRPr sz="1400">
+                <a:solidFill>
+                  <a:srgbClr val="C9D1D9"/>
+                </a:solidFill>
+                <a:latin typeface="Consolas"/>
+              </a:defRPr>
+            </a:pPr>
+          </a:p>
+          <a:p>
+            <a:pPr>
+              <a:spcAft>
+                <a:spcPts val="600"/>
+              </a:spcAft>
+              <a:defRPr sz="1400">
+                <a:solidFill>
+                  <a:srgbClr val="C9D1D9"/>
+                </a:solidFill>
+                <a:latin typeface="Consolas"/>
+              </a:defRPr>
+            </a:pPr>
+            <a:r>
+              <a:t>  Phase 3: ML frequency calculations</a:t>
+            </a:r>
+          </a:p>
+          <a:p>
+            <a:pPr>
+              <a:spcAft>
+                <a:spcPts val="600"/>
+              </a:spcAft>
+              <a:defRPr sz="1400">
+                <a:solidFill>
+                  <a:srgbClr val="C9D1D9"/>
+                </a:solidFill>
+                <a:latin typeface="Consolas"/>
+              </a:defRPr>
+            </a:pPr>
+            <a:r>
+              <a:t>    → Multiple energy-dipole combinations</a:t>
+            </a:r>
+          </a:p>
+          <a:p>
+            <a:pPr>
+              <a:spcAft>
+                <a:spcPts val="600"/>
+              </a:spcAft>
+              <a:defRPr sz="1400">
+                <a:solidFill>
+                  <a:srgbClr val="C9D1D9"/>
+                </a:solidFill>
+                <a:latin typeface="Consolas"/>
+              </a:defRPr>
+            </a:pPr>
+          </a:p>
+          <a:p>
+            <a:pPr>
+              <a:spcAft>
+                <a:spcPts val="600"/>
+              </a:spcAft>
+              <a:defRPr sz="1400">
+                <a:solidFill>
+                  <a:srgbClr val="C9D1D9"/>
+                </a:solidFill>
+                <a:latin typeface="Consolas"/>
+              </a:defRPr>
+            </a:pPr>
+            <a:r>
+              <a:t>  Phase 4: Analysis &amp; comparison</a:t>
+            </a:r>
+          </a:p>
+          <a:p>
+            <a:pPr>
+              <a:spcAft>
+                <a:spcPts val="600"/>
+              </a:spcAft>
+              <a:defRPr sz="1400">
+                <a:solidFill>
+                  <a:srgbClr val="C9D1D9"/>
+                </a:solidFill>
+                <a:latin typeface="Consolas"/>
+              </a:defRPr>
+            </a:pPr>
+            <a:r>
+              <a:t>    → Statistics, plots, HTML report</a:t>
             </a:r>
           </a:p>
         </p:txBody>
@@ -3537,7 +3531,7 @@
               </a:defRPr>
             </a:pPr>
             <a:r>
-              <a:t>Your Name · Research Group · 2025-11-15</a:t>
+              <a:t>Manuel Ott · Hofer Lab · 2025-11-19</a:t>
             </a:r>
           </a:p>
         </p:txBody>
@@ -3654,39 +3648,55 @@
               </a:defRPr>
             </a:pPr>
             <a:r>
-              <a:t>  → Proof of concept validated</a:t>
-            </a:r>
-          </a:p>
-          <a:p>
-            <a:pPr>
-              <a:spcAft>
-                <a:spcPts val="600"/>
-              </a:spcAft>
-              <a:defRPr sz="1400">
-                <a:solidFill>
-                  <a:srgbClr val="C9D1D9"/>
-                </a:solidFill>
-                <a:latin typeface="Consolas"/>
-              </a:defRPr>
-            </a:pPr>
-            <a:r>
-              <a:t>  → Water &amp; acetic acid benchmarks</a:t>
-            </a:r>
-          </a:p>
-          <a:p>
-            <a:pPr>
-              <a:spcAft>
-                <a:spcPts val="600"/>
-              </a:spcAft>
-              <a:defRPr sz="1400">
-                <a:solidFill>
-                  <a:srgbClr val="C9D1D9"/>
-                </a:solidFill>
-                <a:latin typeface="Consolas"/>
-              </a:defRPr>
-            </a:pPr>
-            <a:r>
-              <a:t>  → Automated analysis pipeline</a:t>
+              <a:t>  → ZMQ bridge implemented &amp; working</a:t>
+            </a:r>
+          </a:p>
+          <a:p>
+            <a:pPr>
+              <a:spcAft>
+                <a:spcPts val="600"/>
+              </a:spcAft>
+              <a:defRPr sz="1400">
+                <a:solidFill>
+                  <a:srgbClr val="C9D1D9"/>
+                </a:solidFill>
+                <a:latin typeface="Consolas"/>
+              </a:defRPr>
+            </a:pPr>
+            <a:r>
+              <a:t>  → Water benchmark validated</a:t>
+            </a:r>
+          </a:p>
+          <a:p>
+            <a:pPr>
+              <a:spcAft>
+                <a:spcPts val="600"/>
+              </a:spcAft>
+              <a:defRPr sz="1400">
+                <a:solidFill>
+                  <a:srgbClr val="C9D1D9"/>
+                </a:solidFill>
+                <a:latin typeface="Consolas"/>
+              </a:defRPr>
+            </a:pPr>
+            <a:r>
+              <a:t>  → Automated 4-phase pipeline</a:t>
+            </a:r>
+          </a:p>
+          <a:p>
+            <a:pPr>
+              <a:spcAft>
+                <a:spcPts val="600"/>
+              </a:spcAft>
+              <a:defRPr sz="1400">
+                <a:solidFill>
+                  <a:srgbClr val="C9D1D9"/>
+                </a:solidFill>
+                <a:latin typeface="Consolas"/>
+              </a:defRPr>
+            </a:pPr>
+            <a:r>
+              <a:t>  → Multiple calculator combinations</a:t>
             </a:r>
           </a:p>
           <a:p>
@@ -3731,55 +3741,55 @@
               </a:defRPr>
             </a:pPr>
             <a:r>
-              <a:t>  → Expand molecular test set</a:t>
-            </a:r>
-          </a:p>
-          <a:p>
-            <a:pPr>
-              <a:spcAft>
-                <a:spcPts val="600"/>
-              </a:spcAft>
-              <a:defRPr sz="1400">
-                <a:solidFill>
-                  <a:srgbClr val="C9D1D9"/>
-                </a:solidFill>
-                <a:latin typeface="Consolas"/>
-              </a:defRPr>
-            </a:pPr>
-            <a:r>
-              <a:t>  → Support ORCA quantum chemistry</a:t>
-            </a:r>
-          </a:p>
-          <a:p>
-            <a:pPr>
-              <a:spcAft>
-                <a:spcPts val="600"/>
-              </a:spcAft>
-              <a:defRPr sz="1400">
-                <a:solidFill>
-                  <a:srgbClr val="C9D1D9"/>
-                </a:solidFill>
-                <a:latin typeface="Consolas"/>
-              </a:defRPr>
-            </a:pPr>
-            <a:r>
-              <a:t>  → Additional ML potentials</a:t>
-            </a:r>
-          </a:p>
-          <a:p>
-            <a:pPr>
-              <a:spcAft>
-                <a:spcPts val="600"/>
-              </a:spcAft>
-              <a:defRPr sz="1400">
-                <a:solidFill>
-                  <a:srgbClr val="C9D1D9"/>
-                </a:solidFill>
-                <a:latin typeface="Consolas"/>
-              </a:defRPr>
-            </a:pPr>
-            <a:r>
-              <a:t>  → Optimize dipole model training</a:t>
+              <a:t>  → Expand to larger molecules</a:t>
+            </a:r>
+          </a:p>
+          <a:p>
+            <a:pPr>
+              <a:spcAft>
+                <a:spcPts val="600"/>
+              </a:spcAft>
+              <a:defRPr sz="1400">
+                <a:solidFill>
+                  <a:srgbClr val="C9D1D9"/>
+                </a:solidFill>
+                <a:latin typeface="Consolas"/>
+              </a:defRPr>
+            </a:pPr>
+            <a:r>
+              <a:t>  → Anharmonic frequency analysis</a:t>
+            </a:r>
+          </a:p>
+          <a:p>
+            <a:pPr>
+              <a:spcAft>
+                <a:spcPts val="600"/>
+              </a:spcAft>
+              <a:defRPr sz="1400">
+                <a:solidFill>
+                  <a:srgbClr val="C9D1D9"/>
+                </a:solidFill>
+                <a:latin typeface="Consolas"/>
+              </a:defRPr>
+            </a:pPr>
+            <a:r>
+              <a:t>  → Optimize MACE-ML dipole model</a:t>
+            </a:r>
+          </a:p>
+          <a:p>
+            <a:pPr>
+              <a:spcAft>
+                <a:spcPts val="600"/>
+              </a:spcAft>
+              <a:defRPr sz="1400">
+                <a:solidFill>
+                  <a:srgbClr val="C9D1D9"/>
+                </a:solidFill>
+                <a:latin typeface="Consolas"/>
+              </a:defRPr>
+            </a:pPr>
+            <a:r>
+              <a:t>  → ORCA support (beyond Gaussian)</a:t>
             </a:r>
           </a:p>
           <a:p>
@@ -3808,7 +3818,7 @@
               </a:defRPr>
             </a:pPr>
             <a:r>
-              <a:t># Vision</a:t>
+              <a:t># Long-term Vision</a:t>
             </a:r>
           </a:p>
           <a:p>
@@ -3860,7 +3870,7 @@
               </a:defRPr>
             </a:pPr>
             <a:r>
-              <a:t>Your Name · Research Group · 2025-11-15</a:t>
+              <a:t>Manuel Ott · Hofer Lab · 2025-11-19</a:t>
             </a:r>
           </a:p>
         </p:txBody>
@@ -3977,39 +3987,39 @@
               </a:defRPr>
             </a:pPr>
             <a:r>
-              <a:t>  → DFT anharmonic: computationally expensive</a:t>
-            </a:r>
-          </a:p>
-          <a:p>
-            <a:pPr>
-              <a:spcAft>
-                <a:spcPts val="600"/>
-              </a:spcAft>
-              <a:defRPr sz="1400">
-                <a:solidFill>
-                  <a:srgbClr val="C9D1D9"/>
-                </a:solidFill>
-                <a:latin typeface="Consolas"/>
-              </a:defRPr>
-            </a:pPr>
-            <a:r>
-              <a:t>  → Hours to days per molecule</a:t>
-            </a:r>
-          </a:p>
-          <a:p>
-            <a:pPr>
-              <a:spcAft>
-                <a:spcPts val="600"/>
-              </a:spcAft>
-              <a:defRPr sz="1400">
-                <a:solidFill>
-                  <a:srgbClr val="C9D1D9"/>
-                </a:solidFill>
-                <a:latin typeface="Consolas"/>
-              </a:defRPr>
-            </a:pPr>
-            <a:r>
-              <a:t>  → Limited throughput for screening</a:t>
+              <a:t>  → DFT frequency calculations: slow</a:t>
+            </a:r>
+          </a:p>
+          <a:p>
+            <a:pPr>
+              <a:spcAft>
+                <a:spcPts val="600"/>
+              </a:spcAft>
+              <a:defRPr sz="1400">
+                <a:solidFill>
+                  <a:srgbClr val="C9D1D9"/>
+                </a:solidFill>
+                <a:latin typeface="Consolas"/>
+              </a:defRPr>
+            </a:pPr>
+            <a:r>
+              <a:t>  → Minutes to hours per molecule</a:t>
+            </a:r>
+          </a:p>
+          <a:p>
+            <a:pPr>
+              <a:spcAft>
+                <a:spcPts val="600"/>
+              </a:spcAft>
+              <a:defRPr sz="1400">
+                <a:solidFill>
+                  <a:srgbClr val="C9D1D9"/>
+                </a:solidFill>
+                <a:latin typeface="Consolas"/>
+              </a:defRPr>
+            </a:pPr>
+            <a:r>
+              <a:t>  → Bottleneck for high-throughput screening</a:t>
             </a:r>
           </a:p>
           <a:p>
@@ -4054,39 +4064,39 @@
               </a:defRPr>
             </a:pPr>
             <a:r>
-              <a:t>  → ML potentials: 10-100× faster</a:t>
-            </a:r>
-          </a:p>
-          <a:p>
-            <a:pPr>
-              <a:spcAft>
-                <a:spcPts val="600"/>
-              </a:spcAft>
-              <a:defRPr sz="1400">
-                <a:solidFill>
-                  <a:srgbClr val="C9D1D9"/>
-                </a:solidFill>
-                <a:latin typeface="Consolas"/>
-              </a:defRPr>
-            </a:pPr>
-            <a:r>
-              <a:t>  → Maintain accuracy via hybrid approach</a:t>
-            </a:r>
-          </a:p>
-          <a:p>
-            <a:pPr>
-              <a:spcAft>
-                <a:spcPts val="600"/>
-              </a:spcAft>
-              <a:defRPr sz="1400">
-                <a:solidFill>
-                  <a:srgbClr val="C9D1D9"/>
-                </a:solidFill>
-                <a:latin typeface="Consolas"/>
-              </a:defRPr>
-            </a:pPr>
-            <a:r>
-              <a:t>  → Enable high-throughput predictions</a:t>
+              <a:t>  → Hybrid ML-QM approach</a:t>
+            </a:r>
+          </a:p>
+          <a:p>
+            <a:pPr>
+              <a:spcAft>
+                <a:spcPts val="600"/>
+              </a:spcAft>
+              <a:defRPr sz="1400">
+                <a:solidFill>
+                  <a:srgbClr val="C9D1D9"/>
+                </a:solidFill>
+                <a:latin typeface="Consolas"/>
+              </a:defRPr>
+            </a:pPr>
+            <a:r>
+              <a:t>  → ML dipole derivatives via ZMQ bridge</a:t>
+            </a:r>
+          </a:p>
+          <a:p>
+            <a:pPr>
+              <a:spcAft>
+                <a:spcPts val="600"/>
+              </a:spcAft>
+              <a:defRPr sz="1400">
+                <a:solidFill>
+                  <a:srgbClr val="C9D1D9"/>
+                </a:solidFill>
+                <a:latin typeface="Consolas"/>
+              </a:defRPr>
+            </a:pPr>
+            <a:r>
+              <a:t>  → 10-100× faster than pure DFT</a:t>
             </a:r>
           </a:p>
           <a:p>
@@ -4131,23 +4141,23 @@
               </a:defRPr>
             </a:pPr>
             <a:r>
-              <a:t>  → Rapid spectral database generation</a:t>
-            </a:r>
-          </a:p>
-          <a:p>
-            <a:pPr>
-              <a:spcAft>
-                <a:spcPts val="600"/>
-              </a:spcAft>
-              <a:defRPr sz="1400">
-                <a:solidFill>
-                  <a:srgbClr val="C9D1D9"/>
-                </a:solidFill>
-                <a:latin typeface="Consolas"/>
-              </a:defRPr>
-            </a:pPr>
-            <a:r>
-              <a:t>  → Practical molecular screening</a:t>
+              <a:t>  → Enable rapid IR spectral predictions</a:t>
+            </a:r>
+          </a:p>
+          <a:p>
+            <a:pPr>
+              <a:spcAft>
+                <a:spcPts val="600"/>
+              </a:spcAft>
+              <a:defRPr sz="1400">
+                <a:solidFill>
+                  <a:srgbClr val="C9D1D9"/>
+                </a:solidFill>
+                <a:latin typeface="Consolas"/>
+              </a:defRPr>
+            </a:pPr>
+            <a:r>
+              <a:t>  → Maintain DFT-level accuracy</a:t>
             </a:r>
           </a:p>
         </p:txBody>
@@ -4183,7 +4193,7 @@
               </a:defRPr>
             </a:pPr>
             <a:r>
-              <a:t>Your Name · Research Group · 2025-11-15</a:t>
+              <a:t>Manuel Ott · Hofer Lab · 2025-11-19</a:t>
             </a:r>
           </a:p>
         </p:txBody>
@@ -4390,71 +4400,71 @@
               </a:defRPr>
             </a:pPr>
             <a:r>
-              <a:t># Components</a:t>
-            </a:r>
-          </a:p>
-          <a:p>
-            <a:pPr>
-              <a:spcAft>
-                <a:spcPts val="600"/>
-              </a:spcAft>
-              <a:defRPr sz="1400">
-                <a:solidFill>
-                  <a:srgbClr val="C9D1D9"/>
-                </a:solidFill>
-                <a:latin typeface="Consolas"/>
-              </a:defRPr>
-            </a:pPr>
-            <a:r>
-              <a:t>  → Geometry optimization: MACE-OMOL</a:t>
-            </a:r>
-          </a:p>
-          <a:p>
-            <a:pPr>
-              <a:spcAft>
-                <a:spcPts val="600"/>
-              </a:spcAft>
-              <a:defRPr sz="1400">
-                <a:solidFill>
-                  <a:srgbClr val="C9D1D9"/>
-                </a:solidFill>
-                <a:latin typeface="Consolas"/>
-              </a:defRPr>
-            </a:pPr>
-            <a:r>
-              <a:t>  → Energy calculation: Gaussian/MACE-MP</a:t>
-            </a:r>
-          </a:p>
-          <a:p>
-            <a:pPr>
-              <a:spcAft>
-                <a:spcPts val="600"/>
-              </a:spcAft>
-              <a:defRPr sz="1400">
-                <a:solidFill>
-                  <a:srgbClr val="C9D1D9"/>
-                </a:solidFill>
-                <a:latin typeface="Consolas"/>
-              </a:defRPr>
-            </a:pPr>
-            <a:r>
-              <a:t>  → Dipole derivatives: ML calculators</a:t>
-            </a:r>
-          </a:p>
-          <a:p>
-            <a:pPr>
-              <a:spcAft>
-                <a:spcPts val="600"/>
-              </a:spcAft>
-              <a:defRPr sz="1400">
-                <a:solidFill>
-                  <a:srgbClr val="C9D1D9"/>
-                </a:solidFill>
-                <a:latin typeface="Consolas"/>
-              </a:defRPr>
-            </a:pPr>
-            <a:r>
-              <a:t>  → Anharmonic analysis: Gaussian VPT2</a:t>
+              <a:t># Workflow Phases</a:t>
+            </a:r>
+          </a:p>
+          <a:p>
+            <a:pPr>
+              <a:spcAft>
+                <a:spcPts val="600"/>
+              </a:spcAft>
+              <a:defRPr sz="1400">
+                <a:solidFill>
+                  <a:srgbClr val="C9D1D9"/>
+                </a:solidFill>
+                <a:latin typeface="Consolas"/>
+              </a:defRPr>
+            </a:pPr>
+            <a:r>
+              <a:t>  1. Geometry optimization (MACE-OMOL)</a:t>
+            </a:r>
+          </a:p>
+          <a:p>
+            <a:pPr>
+              <a:spcAft>
+                <a:spcPts val="600"/>
+              </a:spcAft>
+              <a:defRPr sz="1400">
+                <a:solidFill>
+                  <a:srgbClr val="C9D1D9"/>
+                </a:solidFill>
+                <a:latin typeface="Consolas"/>
+              </a:defRPr>
+            </a:pPr>
+            <a:r>
+              <a:t>  2. DFT baseline (B3LYP/6-31G(d,p))</a:t>
+            </a:r>
+          </a:p>
+          <a:p>
+            <a:pPr>
+              <a:spcAft>
+                <a:spcPts val="600"/>
+              </a:spcAft>
+              <a:defRPr sz="1400">
+                <a:solidFill>
+                  <a:srgbClr val="C9D1D9"/>
+                </a:solidFill>
+                <a:latin typeface="Consolas"/>
+              </a:defRPr>
+            </a:pPr>
+            <a:r>
+              <a:t>  3. ML frequency calculations</a:t>
+            </a:r>
+          </a:p>
+          <a:p>
+            <a:pPr>
+              <a:spcAft>
+                <a:spcPts val="600"/>
+              </a:spcAft>
+              <a:defRPr sz="1400">
+                <a:solidFill>
+                  <a:srgbClr val="C9D1D9"/>
+                </a:solidFill>
+                <a:latin typeface="Consolas"/>
+              </a:defRPr>
+            </a:pPr>
+            <a:r>
+              <a:t>  4. Statistical comparison &amp; analysis</a:t>
             </a:r>
           </a:p>
         </p:txBody>
@@ -4490,7 +4500,7 @@
               </a:defRPr>
             </a:pPr>
             <a:r>
-              <a:t>Your Name · Research Group · 2025-11-15</a:t>
+              <a:t>Manuel Ott · Hofer Lab · 2025-11-19</a:t>
             </a:r>
           </a:p>
         </p:txBody>
@@ -4813,7 +4823,7 @@
               </a:defRPr>
             </a:pPr>
             <a:r>
-              <a:t>Your Name · Research Group · 2025-11-15</a:t>
+              <a:t>Manuel Ott · Hofer Lab · 2025-11-19</a:t>
             </a:r>
           </a:p>
         </p:txBody>
@@ -4943,7 +4953,7 @@
               </a:defRPr>
             </a:pPr>
             <a:r>
-              <a:t>drwxr-xr-x  mace_ml/          # Primary</a:t>
+              <a:t>drwxr-xr-x  mace_ml/          # Custom MACE</a:t>
             </a:r>
           </a:p>
           <a:p>
@@ -4959,7 +4969,7 @@
               </a:defRPr>
             </a:pPr>
             <a:r>
-              <a:t>drwxr-xr-x  espaloma/         # Fallback</a:t>
+              <a:t>drwxr-xr-x  espaloma/         # ML charges</a:t>
             </a:r>
           </a:p>
           <a:p>
@@ -4975,23 +4985,7 @@
               </a:defRPr>
             </a:pPr>
             <a:r>
-              <a:t>drwxr-xr-x  xtb/              # Fast</a:t>
-            </a:r>
-          </a:p>
-          <a:p>
-            <a:pPr>
-              <a:spcAft>
-                <a:spcPts val="600"/>
-              </a:spcAft>
-              <a:defRPr sz="1400">
-                <a:solidFill>
-                  <a:srgbClr val="8B949E"/>
-                </a:solidFill>
-                <a:latin typeface="Consolas"/>
-              </a:defRPr>
-            </a:pPr>
-            <a:r>
-              <a:t>drwxr-xr-x  geometry_based/   # Last resort</a:t>
+              <a:t>drwxr-xr-x  xtb/              # Semi-empirical</a:t>
             </a:r>
           </a:p>
           <a:p>
@@ -5020,71 +5014,116 @@
               </a:defRPr>
             </a:pPr>
             <a:r>
-              <a:t># Features</a:t>
-            </a:r>
-          </a:p>
-          <a:p>
-            <a:pPr>
-              <a:spcAft>
-                <a:spcPts val="600"/>
-              </a:spcAft>
-              <a:defRPr sz="1400">
-                <a:solidFill>
-                  <a:srgbClr val="C9D1D9"/>
-                </a:solidFill>
-                <a:latin typeface="Consolas"/>
-              </a:defRPr>
-            </a:pPr>
-            <a:r>
-              <a:t>  → Automatic fallback chain</a:t>
-            </a:r>
-          </a:p>
-          <a:p>
-            <a:pPr>
-              <a:spcAft>
-                <a:spcPts val="600"/>
-              </a:spcAft>
-              <a:defRPr sz="1400">
-                <a:solidFill>
-                  <a:srgbClr val="C9D1D9"/>
-                </a:solidFill>
-                <a:latin typeface="Consolas"/>
-              </a:defRPr>
-            </a:pPr>
-            <a:r>
-              <a:t>  → Custom MACE dipole model</a:t>
-            </a:r>
-          </a:p>
-          <a:p>
-            <a:pPr>
-              <a:spcAft>
-                <a:spcPts val="600"/>
-              </a:spcAft>
-              <a:defRPr sz="1400">
-                <a:solidFill>
-                  <a:srgbClr val="C9D1D9"/>
-                </a:solidFill>
-                <a:latin typeface="Consolas"/>
-              </a:defRPr>
-            </a:pPr>
-            <a:r>
-              <a:t>  → Charge-based dipole (Espaloma)</a:t>
-            </a:r>
-          </a:p>
-          <a:p>
-            <a:pPr>
-              <a:spcAft>
-                <a:spcPts val="600"/>
-              </a:spcAft>
-              <a:defRPr sz="1400">
-                <a:solidFill>
-                  <a:srgbClr val="C9D1D9"/>
-                </a:solidFill>
-                <a:latin typeface="Consolas"/>
-              </a:defRPr>
-            </a:pPr>
-            <a:r>
-              <a:t>  → Semi-empirical xTB backup</a:t>
+              <a:t># Automatic Fallback Chain</a:t>
+            </a:r>
+          </a:p>
+          <a:p>
+            <a:pPr>
+              <a:spcAft>
+                <a:spcPts val="600"/>
+              </a:spcAft>
+              <a:defRPr sz="1400">
+                <a:solidFill>
+                  <a:srgbClr val="C9D1D9"/>
+                </a:solidFill>
+                <a:latin typeface="Consolas"/>
+              </a:defRPr>
+            </a:pPr>
+            <a:r>
+              <a:t>  1. MACE-ML: Custom dipole model</a:t>
+            </a:r>
+          </a:p>
+          <a:p>
+            <a:pPr>
+              <a:spcAft>
+                <a:spcPts val="600"/>
+              </a:spcAft>
+              <a:defRPr sz="1400">
+                <a:solidFill>
+                  <a:srgbClr val="C9D1D9"/>
+                </a:solidFill>
+                <a:latin typeface="Consolas"/>
+              </a:defRPr>
+            </a:pPr>
+            <a:r>
+              <a:t>  2. Espaloma: Charge-based dipoles</a:t>
+            </a:r>
+          </a:p>
+          <a:p>
+            <a:pPr>
+              <a:spcAft>
+                <a:spcPts val="600"/>
+              </a:spcAft>
+              <a:defRPr sz="1400">
+                <a:solidFill>
+                  <a:srgbClr val="C9D1D9"/>
+                </a:solidFill>
+                <a:latin typeface="Consolas"/>
+              </a:defRPr>
+            </a:pPr>
+            <a:r>
+              <a:t>  3. xTB: GFN2-xTB semi-empirical</a:t>
+            </a:r>
+          </a:p>
+          <a:p>
+            <a:pPr>
+              <a:spcAft>
+                <a:spcPts val="600"/>
+              </a:spcAft>
+              <a:defRPr sz="1400">
+                <a:solidFill>
+                  <a:srgbClr val="C9D1D9"/>
+                </a:solidFill>
+                <a:latin typeface="Consolas"/>
+              </a:defRPr>
+            </a:pPr>
+          </a:p>
+          <a:p>
+            <a:pPr>
+              <a:spcAft>
+                <a:spcPts val="600"/>
+              </a:spcAft>
+              <a:defRPr sz="1400">
+                <a:solidFill>
+                  <a:srgbClr val="58A6FF"/>
+                </a:solidFill>
+                <a:latin typeface="Consolas"/>
+              </a:defRPr>
+            </a:pPr>
+            <a:r>
+              <a:t># Implementation</a:t>
+            </a:r>
+          </a:p>
+          <a:p>
+            <a:pPr>
+              <a:spcAft>
+                <a:spcPts val="600"/>
+              </a:spcAft>
+              <a:defRPr sz="1400">
+                <a:solidFill>
+                  <a:srgbClr val="C9D1D9"/>
+                </a:solidFill>
+                <a:latin typeface="Consolas"/>
+              </a:defRPr>
+            </a:pPr>
+            <a:r>
+              <a:t>  → Factory pattern with availability checks</a:t>
+            </a:r>
+          </a:p>
+          <a:p>
+            <a:pPr>
+              <a:spcAft>
+                <a:spcPts val="600"/>
+              </a:spcAft>
+              <a:defRPr sz="1400">
+                <a:solidFill>
+                  <a:srgbClr val="C9D1D9"/>
+                </a:solidFill>
+                <a:latin typeface="Consolas"/>
+              </a:defRPr>
+            </a:pPr>
+            <a:r>
+              <a:t>  → Seamless calculator switching</a:t>
             </a:r>
           </a:p>
         </p:txBody>
@@ -5120,7 +5159,7 @@
               </a:defRPr>
             </a:pPr>
             <a:r>
-              <a:t>Your Name · Research Group · 2025-11-15</a:t>
+              <a:t>Manuel Ott · Hofer Lab · 2025-11-19</a:t>
             </a:r>
           </a:p>
         </p:txBody>
@@ -5440,7 +5479,7 @@
               </a:defRPr>
             </a:pPr>
             <a:r>
-              <a:t>Your Name · Research Group · 2025-11-15</a:t>
+              <a:t>Manuel Ott · Hofer Lab · 2025-11-19</a:t>
             </a:r>
           </a:p>
         </p:txBody>
@@ -5541,68 +5580,68 @@
               </a:defRPr>
             </a:pPr>
             <a:r>
-              <a:t># Eigenvector-Based Matching</a:t>
-            </a:r>
-          </a:p>
-          <a:p>
-            <a:pPr>
-              <a:spcAft>
-                <a:spcPts val="600"/>
-              </a:spcAft>
-              <a:defRPr sz="1400">
-                <a:solidFill>
-                  <a:srgbClr val="C9D1D9"/>
-                </a:solidFill>
-                <a:latin typeface="Consolas"/>
-              </a:defRPr>
-            </a:pPr>
-          </a:p>
-          <a:p>
-            <a:pPr>
-              <a:spcAft>
-                <a:spcPts val="600"/>
-              </a:spcAft>
-              <a:defRPr sz="1400">
-                <a:solidFill>
-                  <a:srgbClr val="C9D1D9"/>
-                </a:solidFill>
-                <a:latin typeface="Consolas"/>
-              </a:defRPr>
-            </a:pPr>
-            <a:r>
-              <a:t>  → Compare DFT vs ML normal modes</a:t>
-            </a:r>
-          </a:p>
-          <a:p>
-            <a:pPr>
-              <a:spcAft>
-                <a:spcPts val="600"/>
-              </a:spcAft>
-              <a:defRPr sz="1400">
-                <a:solidFill>
-                  <a:srgbClr val="C9D1D9"/>
-                </a:solidFill>
-                <a:latin typeface="Consolas"/>
-              </a:defRPr>
-            </a:pPr>
-            <a:r>
-              <a:t>  → Dot product similarity threshold</a:t>
-            </a:r>
-          </a:p>
-          <a:p>
-            <a:pPr>
-              <a:spcAft>
-                <a:spcPts val="600"/>
-              </a:spcAft>
-              <a:defRPr sz="1400">
-                <a:solidFill>
-                  <a:srgbClr val="C9D1D9"/>
-                </a:solidFill>
-                <a:latin typeface="Consolas"/>
-              </a:defRPr>
-            </a:pPr>
-            <a:r>
-              <a:t>  → Handle mode ordering differences</a:t>
+              <a:t># Comparison vs DFT Baseline</a:t>
+            </a:r>
+          </a:p>
+          <a:p>
+            <a:pPr>
+              <a:spcAft>
+                <a:spcPts val="600"/>
+              </a:spcAft>
+              <a:defRPr sz="1400">
+                <a:solidFill>
+                  <a:srgbClr val="C9D1D9"/>
+                </a:solidFill>
+                <a:latin typeface="Consolas"/>
+              </a:defRPr>
+            </a:pPr>
+          </a:p>
+          <a:p>
+            <a:pPr>
+              <a:spcAft>
+                <a:spcPts val="600"/>
+              </a:spcAft>
+              <a:defRPr sz="1400">
+                <a:solidFill>
+                  <a:srgbClr val="C9D1D9"/>
+                </a:solidFill>
+                <a:latin typeface="Consolas"/>
+              </a:defRPr>
+            </a:pPr>
+            <a:r>
+              <a:t>  → B3LYP/6-31G(d,p) reference</a:t>
+            </a:r>
+          </a:p>
+          <a:p>
+            <a:pPr>
+              <a:spcAft>
+                <a:spcPts val="600"/>
+              </a:spcAft>
+              <a:defRPr sz="1400">
+                <a:solidFill>
+                  <a:srgbClr val="C9D1D9"/>
+                </a:solidFill>
+                <a:latin typeface="Consolas"/>
+              </a:defRPr>
+            </a:pPr>
+            <a:r>
+              <a:t>  → Harmonic frequency analysis</a:t>
+            </a:r>
+          </a:p>
+          <a:p>
+            <a:pPr>
+              <a:spcAft>
+                <a:spcPts val="600"/>
+              </a:spcAft>
+              <a:defRPr sz="1400">
+                <a:solidFill>
+                  <a:srgbClr val="C9D1D9"/>
+                </a:solidFill>
+                <a:latin typeface="Consolas"/>
+              </a:defRPr>
+            </a:pPr>
+            <a:r>
+              <a:t>  → Test molecule: Water (H₂O)</a:t>
             </a:r>
           </a:p>
           <a:p>
@@ -5631,7 +5670,7 @@
               </a:defRPr>
             </a:pPr>
             <a:r>
-              <a:t># Metrics</a:t>
+              <a:t># Statistical Metrics</a:t>
             </a:r>
           </a:p>
           <a:p>
@@ -5695,7 +5734,7 @@
               </a:defRPr>
             </a:pPr>
             <a:r>
-              <a:t>  → Slope/intercept analysis</a:t>
+              <a:t>  → Linear regression analysis</a:t>
             </a:r>
           </a:p>
           <a:p>
@@ -5724,7 +5763,23 @@
               </a:defRPr>
             </a:pPr>
             <a:r>
-              <a:t># Spectral Analysis</a:t>
+              <a:t># Visualization</a:t>
+            </a:r>
+          </a:p>
+          <a:p>
+            <a:pPr>
+              <a:spcAft>
+                <a:spcPts val="600"/>
+              </a:spcAft>
+              <a:defRPr sz="1400">
+                <a:solidFill>
+                  <a:srgbClr val="C9D1D9"/>
+                </a:solidFill>
+                <a:latin typeface="Consolas"/>
+              </a:defRPr>
+            </a:pPr>
+            <a:r>
+              <a:t>  → Regression plots (ML vs DFT)</a:t>
             </a:r>
           </a:p>
           <a:p>
@@ -5776,7 +5831,7 @@
               </a:defRPr>
             </a:pPr>
             <a:r>
-              <a:t>Your Name · Research Group · 2025-11-15</a:t>
+              <a:t>Manuel Ott · Hofer Lab · 2025-11-19</a:t>
             </a:r>
           </a:p>
         </p:txBody>
@@ -5838,7 +5893,7 @@
               </a:defRPr>
             </a:pPr>
             <a:r>
-              <a:t>$ python analyze_spectra.py</a:t>
+              <a:t>$ python analyze_spectra.py water</a:t>
             </a:r>
           </a:p>
         </p:txBody>
@@ -5877,68 +5932,84 @@
               </a:defRPr>
             </a:pPr>
             <a:r>
-              <a:t># Frequency Predictions</a:t>
-            </a:r>
-          </a:p>
-          <a:p>
-            <a:pPr>
-              <a:spcAft>
-                <a:spcPts val="600"/>
-              </a:spcAft>
-              <a:defRPr sz="1400">
-                <a:solidFill>
-                  <a:srgbClr val="C9D1D9"/>
-                </a:solidFill>
-                <a:latin typeface="Consolas"/>
-              </a:defRPr>
-            </a:pPr>
-          </a:p>
-          <a:p>
-            <a:pPr>
-              <a:spcAft>
-                <a:spcPts val="600"/>
-              </a:spcAft>
-              <a:defRPr sz="1400">
-                <a:solidFill>
-                  <a:srgbClr val="C9D1D9"/>
-                </a:solidFill>
-                <a:latin typeface="Consolas"/>
-              </a:defRPr>
-            </a:pPr>
-            <a:r>
-              <a:t>Test molecules:</a:t>
-            </a:r>
-          </a:p>
-          <a:p>
-            <a:pPr>
-              <a:spcAft>
-                <a:spcPts val="600"/>
-              </a:spcAft>
-              <a:defRPr sz="1400">
-                <a:solidFill>
-                  <a:srgbClr val="C9D1D9"/>
-                </a:solidFill>
-                <a:latin typeface="Consolas"/>
-              </a:defRPr>
-            </a:pPr>
-            <a:r>
-              <a:t>  → Water (H₂O)</a:t>
-            </a:r>
-          </a:p>
-          <a:p>
-            <a:pPr>
-              <a:spcAft>
-                <a:spcPts val="600"/>
-              </a:spcAft>
-              <a:defRPr sz="1400">
-                <a:solidFill>
-                  <a:srgbClr val="C9D1D9"/>
-                </a:solidFill>
-                <a:latin typeface="Consolas"/>
-              </a:defRPr>
-            </a:pPr>
-            <a:r>
-              <a:t>  → Acetic acid (CH₃COOH)</a:t>
+              <a:t># Water (H₂O) Benchmark</a:t>
+            </a:r>
+          </a:p>
+          <a:p>
+            <a:pPr>
+              <a:spcAft>
+                <a:spcPts val="600"/>
+              </a:spcAft>
+              <a:defRPr sz="1400">
+                <a:solidFill>
+                  <a:srgbClr val="C9D1D9"/>
+                </a:solidFill>
+                <a:latin typeface="Consolas"/>
+              </a:defRPr>
+            </a:pPr>
+          </a:p>
+          <a:p>
+            <a:pPr>
+              <a:spcAft>
+                <a:spcPts val="600"/>
+              </a:spcAft>
+              <a:defRPr sz="1400">
+                <a:solidFill>
+                  <a:srgbClr val="C9D1D9"/>
+                </a:solidFill>
+                <a:latin typeface="Consolas"/>
+              </a:defRPr>
+            </a:pPr>
+            <a:r>
+              <a:t>  → 3 normal modes</a:t>
+            </a:r>
+          </a:p>
+          <a:p>
+            <a:pPr>
+              <a:spcAft>
+                <a:spcPts val="600"/>
+              </a:spcAft>
+              <a:defRPr sz="1400">
+                <a:solidFill>
+                  <a:srgbClr val="C9D1D9"/>
+                </a:solidFill>
+                <a:latin typeface="Consolas"/>
+              </a:defRPr>
+            </a:pPr>
+            <a:r>
+              <a:t>  → Symmetric stretch (~3650 cm⁻¹)</a:t>
+            </a:r>
+          </a:p>
+          <a:p>
+            <a:pPr>
+              <a:spcAft>
+                <a:spcPts val="600"/>
+              </a:spcAft>
+              <a:defRPr sz="1400">
+                <a:solidFill>
+                  <a:srgbClr val="C9D1D9"/>
+                </a:solidFill>
+                <a:latin typeface="Consolas"/>
+              </a:defRPr>
+            </a:pPr>
+            <a:r>
+              <a:t>  → Asymmetric stretch (~3750 cm⁻¹)</a:t>
+            </a:r>
+          </a:p>
+          <a:p>
+            <a:pPr>
+              <a:spcAft>
+                <a:spcPts val="600"/>
+              </a:spcAft>
+              <a:defRPr sz="1400">
+                <a:solidFill>
+                  <a:srgbClr val="C9D1D9"/>
+                </a:solidFill>
+                <a:latin typeface="Consolas"/>
+              </a:defRPr>
+            </a:pPr>
+            <a:r>
+              <a:t>  → Bending mode (~1590 cm⁻¹)</a:t>
             </a:r>
           </a:p>
           <a:p>
@@ -5967,55 +6038,55 @@
               </a:defRPr>
             </a:pPr>
             <a:r>
-              <a:t># Accuracy vs DFT Baseline</a:t>
-            </a:r>
-          </a:p>
-          <a:p>
-            <a:pPr>
-              <a:spcAft>
-                <a:spcPts val="600"/>
-              </a:spcAft>
-              <a:defRPr sz="1400">
-                <a:solidFill>
-                  <a:srgbClr val="C9D1D9"/>
-                </a:solidFill>
-                <a:latin typeface="Consolas"/>
-              </a:defRPr>
-            </a:pPr>
-            <a:r>
-              <a:t>  → Fundamentals:    MAE &lt; 15 cm⁻¹</a:t>
-            </a:r>
-          </a:p>
-          <a:p>
-            <a:pPr>
-              <a:spcAft>
-                <a:spcPts val="600"/>
-              </a:spcAft>
-              <a:defRPr sz="1400">
-                <a:solidFill>
-                  <a:srgbClr val="C9D1D9"/>
-                </a:solidFill>
-                <a:latin typeface="Consolas"/>
-              </a:defRPr>
-            </a:pPr>
-            <a:r>
-              <a:t>  → Overtones:       MAE &lt; 30 cm⁻¹</a:t>
-            </a:r>
-          </a:p>
-          <a:p>
-            <a:pPr>
-              <a:spcAft>
-                <a:spcPts val="600"/>
-              </a:spcAft>
-              <a:defRPr sz="1400">
-                <a:solidFill>
-                  <a:srgbClr val="C9D1D9"/>
-                </a:solidFill>
-                <a:latin typeface="Consolas"/>
-              </a:defRPr>
-            </a:pPr>
-            <a:r>
-              <a:t>  → Combinations:    MAE &lt; 25 cm⁻¹</a:t>
+              <a:t># ML vs DFT Accuracy</a:t>
+            </a:r>
+          </a:p>
+          <a:p>
+            <a:pPr>
+              <a:spcAft>
+                <a:spcPts val="600"/>
+              </a:spcAft>
+              <a:defRPr sz="1400">
+                <a:solidFill>
+                  <a:srgbClr val="C9D1D9"/>
+                </a:solidFill>
+                <a:latin typeface="Consolas"/>
+              </a:defRPr>
+            </a:pPr>
+            <a:r>
+              <a:t>  → MAE: &lt; 20 cm⁻¹</a:t>
+            </a:r>
+          </a:p>
+          <a:p>
+            <a:pPr>
+              <a:spcAft>
+                <a:spcPts val="600"/>
+              </a:spcAft>
+              <a:defRPr sz="1400">
+                <a:solidFill>
+                  <a:srgbClr val="C9D1D9"/>
+                </a:solidFill>
+                <a:latin typeface="Consolas"/>
+              </a:defRPr>
+            </a:pPr>
+            <a:r>
+              <a:t>  → RMSE: &lt; 25 cm⁻¹</a:t>
+            </a:r>
+          </a:p>
+          <a:p>
+            <a:pPr>
+              <a:spcAft>
+                <a:spcPts val="600"/>
+              </a:spcAft>
+              <a:defRPr sz="1400">
+                <a:solidFill>
+                  <a:srgbClr val="C9D1D9"/>
+                </a:solidFill>
+                <a:latin typeface="Consolas"/>
+              </a:defRPr>
+            </a:pPr>
+            <a:r>
+              <a:t>  → R²: &gt; 0.99</a:t>
             </a:r>
           </a:p>
           <a:p>
@@ -6044,23 +6115,23 @@
               </a:defRPr>
             </a:pPr>
             <a:r>
-              <a:t># Performance</a:t>
-            </a:r>
-          </a:p>
-          <a:p>
-            <a:pPr>
-              <a:spcAft>
-                <a:spcPts val="600"/>
-              </a:spcAft>
-              <a:defRPr sz="1400">
-                <a:solidFill>
-                  <a:srgbClr val="C9D1D9"/>
-                </a:solidFill>
-                <a:latin typeface="Consolas"/>
-              </a:defRPr>
-            </a:pPr>
-            <a:r>
-              <a:t>  → 50-100× speedup over pure DFT</a:t>
+              <a:t># Computational Speedup</a:t>
+            </a:r>
+          </a:p>
+          <a:p>
+            <a:pPr>
+              <a:spcAft>
+                <a:spcPts val="600"/>
+              </a:spcAft>
+              <a:defRPr sz="1400">
+                <a:solidFill>
+                  <a:srgbClr val="C9D1D9"/>
+                </a:solidFill>
+                <a:latin typeface="Consolas"/>
+              </a:defRPr>
+            </a:pPr>
+            <a:r>
+              <a:t>  → 50-100× faster than pure DFT</a:t>
             </a:r>
           </a:p>
         </p:txBody>
@@ -6096,7 +6167,7 @@
               </a:defRPr>
             </a:pPr>
             <a:r>
-              <a:t>Your Name · Research Group · 2025-11-15</a:t>
+              <a:t>Manuel Ott · Hofer Lab · 2025-11-19</a:t>
             </a:r>
           </a:p>
         </p:txBody>
@@ -6158,7 +6229,7 @@
               </a:defRPr>
             </a:pPr>
             <a:r>
-              <a:t>$ grep 'overtone' results.json</a:t>
+              <a:t>$ cat config.yaml</a:t>
             </a:r>
           </a:p>
         </p:txBody>
@@ -6197,68 +6268,68 @@
               </a:defRPr>
             </a:pPr>
             <a:r>
-              <a:t># Anharmonic Analysis</a:t>
-            </a:r>
-          </a:p>
-          <a:p>
-            <a:pPr>
-              <a:spcAft>
-                <a:spcPts val="600"/>
-              </a:spcAft>
-              <a:defRPr sz="1400">
-                <a:solidFill>
-                  <a:srgbClr val="C9D1D9"/>
-                </a:solidFill>
-                <a:latin typeface="Consolas"/>
-              </a:defRPr>
-            </a:pPr>
-          </a:p>
-          <a:p>
-            <a:pPr>
-              <a:spcAft>
-                <a:spcPts val="600"/>
-              </a:spcAft>
-              <a:defRPr sz="1400">
-                <a:solidFill>
-                  <a:srgbClr val="C9D1D9"/>
-                </a:solidFill>
-                <a:latin typeface="Consolas"/>
-              </a:defRPr>
-            </a:pPr>
-            <a:r>
-              <a:t>  → Gaussian VPT2 framework</a:t>
-            </a:r>
-          </a:p>
-          <a:p>
-            <a:pPr>
-              <a:spcAft>
-                <a:spcPts val="600"/>
-              </a:spcAft>
-              <a:defRPr sz="1400">
-                <a:solidFill>
-                  <a:srgbClr val="C9D1D9"/>
-                </a:solidFill>
-                <a:latin typeface="Consolas"/>
-              </a:defRPr>
-            </a:pPr>
-            <a:r>
-              <a:t>  → Overtones: 2ν₁, 2ν₂, ...</a:t>
-            </a:r>
-          </a:p>
-          <a:p>
-            <a:pPr>
-              <a:spcAft>
-                <a:spcPts val="600"/>
-              </a:spcAft>
-              <a:defRPr sz="1400">
-                <a:solidFill>
-                  <a:srgbClr val="C9D1D9"/>
-                </a:solidFill>
-                <a:latin typeface="Consolas"/>
-              </a:defRPr>
-            </a:pPr>
-            <a:r>
-              <a:t>  → Combination bands: ν₁+ν₂, ν₁+ν₃, ...</a:t>
+              <a:t># Energy Calculators</a:t>
+            </a:r>
+          </a:p>
+          <a:p>
+            <a:pPr>
+              <a:spcAft>
+                <a:spcPts val="600"/>
+              </a:spcAft>
+              <a:defRPr sz="1400">
+                <a:solidFill>
+                  <a:srgbClr val="C9D1D9"/>
+                </a:solidFill>
+                <a:latin typeface="Consolas"/>
+              </a:defRPr>
+            </a:pPr>
+          </a:p>
+          <a:p>
+            <a:pPr>
+              <a:spcAft>
+                <a:spcPts val="600"/>
+              </a:spcAft>
+              <a:defRPr sz="1400">
+                <a:solidFill>
+                  <a:srgbClr val="C9D1D9"/>
+                </a:solidFill>
+                <a:latin typeface="Consolas"/>
+              </a:defRPr>
+            </a:pPr>
+            <a:r>
+              <a:t>  → MACE-MP (large, general)</a:t>
+            </a:r>
+          </a:p>
+          <a:p>
+            <a:pPr>
+              <a:spcAft>
+                <a:spcPts val="600"/>
+              </a:spcAft>
+              <a:defRPr sz="1400">
+                <a:solidFill>
+                  <a:srgbClr val="C9D1D9"/>
+                </a:solidFill>
+                <a:latin typeface="Consolas"/>
+              </a:defRPr>
+            </a:pPr>
+            <a:r>
+              <a:t>  → MACE-OMOL (molecules, default)</a:t>
+            </a:r>
+          </a:p>
+          <a:p>
+            <a:pPr>
+              <a:spcAft>
+                <a:spcPts val="600"/>
+              </a:spcAft>
+              <a:defRPr sz="1400">
+                <a:solidFill>
+                  <a:srgbClr val="C9D1D9"/>
+                </a:solidFill>
+                <a:latin typeface="Consolas"/>
+              </a:defRPr>
+            </a:pPr>
+            <a:r>
+              <a:t>  → MACE-OFF (alternative foundation)</a:t>
             </a:r>
           </a:p>
           <a:p>
@@ -6287,55 +6358,39 @@
               </a:defRPr>
             </a:pPr>
             <a:r>
-              <a:t># Parser Implementation</a:t>
-            </a:r>
-          </a:p>
-          <a:p>
-            <a:pPr>
-              <a:spcAft>
-                <a:spcPts val="600"/>
-              </a:spcAft>
-              <a:defRPr sz="1400">
-                <a:solidFill>
-                  <a:srgbClr val="C9D1D9"/>
-                </a:solidFill>
-                <a:latin typeface="Consolas"/>
-              </a:defRPr>
-            </a:pPr>
-            <a:r>
-              <a:t>  → Regex matching for 2(X) patterns</a:t>
-            </a:r>
-          </a:p>
-          <a:p>
-            <a:pPr>
-              <a:spcAft>
-                <a:spcPts val="600"/>
-              </a:spcAft>
-              <a:defRPr sz="1400">
-                <a:solidFill>
-                  <a:srgbClr val="C9D1D9"/>
-                </a:solidFill>
-                <a:latin typeface="Consolas"/>
-              </a:defRPr>
-            </a:pPr>
-            <a:r>
-              <a:t>  → Handle X(1) + Y(1) combinations</a:t>
-            </a:r>
-          </a:p>
-          <a:p>
-            <a:pPr>
-              <a:spcAft>
-                <a:spcPts val="600"/>
-              </a:spcAft>
-              <a:defRPr sz="1400">
-                <a:solidFill>
-                  <a:srgbClr val="C9D1D9"/>
-                </a:solidFill>
-                <a:latin typeface="Consolas"/>
-              </a:defRPr>
-            </a:pPr>
-            <a:r>
-              <a:t>  → Separate harmonic/anharmonic sections</a:t>
+              <a:t># Dipole Calculators</a:t>
+            </a:r>
+          </a:p>
+          <a:p>
+            <a:pPr>
+              <a:spcAft>
+                <a:spcPts val="600"/>
+              </a:spcAft>
+              <a:defRPr sz="1400">
+                <a:solidFill>
+                  <a:srgbClr val="C9D1D9"/>
+                </a:solidFill>
+                <a:latin typeface="Consolas"/>
+              </a:defRPr>
+            </a:pPr>
+            <a:r>
+              <a:t>  → Espaloma (charge-based)</a:t>
+            </a:r>
+          </a:p>
+          <a:p>
+            <a:pPr>
+              <a:spcAft>
+                <a:spcPts val="600"/>
+              </a:spcAft>
+              <a:defRPr sz="1400">
+                <a:solidFill>
+                  <a:srgbClr val="C9D1D9"/>
+                </a:solidFill>
+                <a:latin typeface="Consolas"/>
+              </a:defRPr>
+            </a:pPr>
+            <a:r>
+              <a:t>  → MACE-ML (custom dipole model)</a:t>
             </a:r>
           </a:p>
           <a:p>
@@ -6364,39 +6419,71 @@
               </a:defRPr>
             </a:pPr>
             <a:r>
-              <a:t># Challenges</a:t>
-            </a:r>
-          </a:p>
-          <a:p>
-            <a:pPr>
-              <a:spcAft>
-                <a:spcPts val="600"/>
-              </a:spcAft>
-              <a:defRPr sz="1400">
-                <a:solidFill>
-                  <a:srgbClr val="C9D1D9"/>
-                </a:solidFill>
-                <a:latin typeface="Consolas"/>
-              </a:defRPr>
-            </a:pPr>
-            <a:r>
-              <a:t>  → Missing anharmonic data in some calcs</a:t>
-            </a:r>
-          </a:p>
-          <a:p>
-            <a:pPr>
-              <a:spcAft>
-                <a:spcPts val="600"/>
-              </a:spcAft>
-              <a:defRPr sz="1400">
-                <a:solidFill>
-                  <a:srgbClr val="C9D1D9"/>
-                </a:solidFill>
-                <a:latin typeface="Consolas"/>
-              </a:defRPr>
-            </a:pPr>
-            <a:r>
-              <a:t>  → Mode numbering consistency</a:t>
+              <a:t># Tested Combinations</a:t>
+            </a:r>
+          </a:p>
+          <a:p>
+            <a:pPr>
+              <a:spcAft>
+                <a:spcPts val="600"/>
+              </a:spcAft>
+              <a:defRPr sz="1400">
+                <a:solidFill>
+                  <a:srgbClr val="C9D1D9"/>
+                </a:solidFill>
+                <a:latin typeface="Consolas"/>
+              </a:defRPr>
+            </a:pPr>
+            <a:r>
+              <a:t>  → mace_mp + espaloma</a:t>
+            </a:r>
+          </a:p>
+          <a:p>
+            <a:pPr>
+              <a:spcAft>
+                <a:spcPts val="600"/>
+              </a:spcAft>
+              <a:defRPr sz="1400">
+                <a:solidFill>
+                  <a:srgbClr val="C9D1D9"/>
+                </a:solidFill>
+                <a:latin typeface="Consolas"/>
+              </a:defRPr>
+            </a:pPr>
+            <a:r>
+              <a:t>  → mace_omol + espaloma</a:t>
+            </a:r>
+          </a:p>
+          <a:p>
+            <a:pPr>
+              <a:spcAft>
+                <a:spcPts val="600"/>
+              </a:spcAft>
+              <a:defRPr sz="1400">
+                <a:solidFill>
+                  <a:srgbClr val="C9D1D9"/>
+                </a:solidFill>
+                <a:latin typeface="Consolas"/>
+              </a:defRPr>
+            </a:pPr>
+            <a:r>
+              <a:t>  → mace_mp + mace_ml</a:t>
+            </a:r>
+          </a:p>
+          <a:p>
+            <a:pPr>
+              <a:spcAft>
+                <a:spcPts val="600"/>
+              </a:spcAft>
+              <a:defRPr sz="1400">
+                <a:solidFill>
+                  <a:srgbClr val="C9D1D9"/>
+                </a:solidFill>
+                <a:latin typeface="Consolas"/>
+              </a:defRPr>
+            </a:pPr>
+            <a:r>
+              <a:t>  → All compared vs DFT baseline</a:t>
             </a:r>
           </a:p>
         </p:txBody>
@@ -6432,7 +6519,7 @@
               </a:defRPr>
             </a:pPr>
             <a:r>
-              <a:t>Your Name · Research Group · 2025-11-15</a:t>
+              <a:t>Manuel Ott · Hofer Lab · 2025-11-19</a:t>
             </a:r>
           </a:p>
         </p:txBody>

</xml_diff>

<commit_message>
Add page numbers and workflow flowchart test slides
Main presentation updates:
- Added page numbers in bottom right (starting at 1 on slide 2)
- Title slide has no page number
- Content slides numbered 1-10

New test file: test_workflow_flowcharts.pptx
- 4 different ASCII flowchart styles for the workflow
- Vertical flowchart (top to bottom)
- Horizontal flowchart (left to right)
- Detailed flowchart (with double-line borders)
- Compact flowchart (minimalist tree-style)
- All using terminal dark theme with ASCII art
</commit_message>
<xml_diff>
--- a/presentation/mace_gaussian_presentation.pptx
+++ b/presentation/mace_gaussian_presentation.pptx
@@ -3536,6 +3536,42 @@
           </a:p>
         </p:txBody>
       </p:sp>
+      <p:sp>
+        <p:nvSpPr>
+          <p:cNvPr id="5" name="TextBox 4"/>
+          <p:cNvSpPr txBox="1"/>
+          <p:nvPr/>
+        </p:nvSpPr>
+        <p:spPr>
+          <a:xfrm>
+            <a:off x="7772400" y="6309360"/>
+            <a:ext cx="914400" cy="365760"/>
+          </a:xfrm>
+          <a:prstGeom prst="rect">
+            <a:avLst/>
+          </a:prstGeom>
+          <a:noFill/>
+        </p:spPr>
+        <p:txBody>
+          <a:bodyPr wrap="none">
+            <a:spAutoFit/>
+          </a:bodyPr>
+          <a:lstStyle/>
+          <a:p>
+            <a:pPr algn="r">
+              <a:defRPr sz="1200">
+                <a:solidFill>
+                  <a:srgbClr val="8B949E"/>
+                </a:solidFill>
+                <a:latin typeface="Consolas"/>
+              </a:defRPr>
+            </a:pPr>
+            <a:r>
+              <a:t>9</a:t>
+            </a:r>
+          </a:p>
+        </p:txBody>
+      </p:sp>
     </p:spTree>
   </p:cSld>
   <p:clrMapOvr>
@@ -3875,6 +3911,42 @@
           </a:p>
         </p:txBody>
       </p:sp>
+      <p:sp>
+        <p:nvSpPr>
+          <p:cNvPr id="5" name="TextBox 4"/>
+          <p:cNvSpPr txBox="1"/>
+          <p:nvPr/>
+        </p:nvSpPr>
+        <p:spPr>
+          <a:xfrm>
+            <a:off x="7772400" y="6309360"/>
+            <a:ext cx="914400" cy="365760"/>
+          </a:xfrm>
+          <a:prstGeom prst="rect">
+            <a:avLst/>
+          </a:prstGeom>
+          <a:noFill/>
+        </p:spPr>
+        <p:txBody>
+          <a:bodyPr wrap="none">
+            <a:spAutoFit/>
+          </a:bodyPr>
+          <a:lstStyle/>
+          <a:p>
+            <a:pPr algn="r">
+              <a:defRPr sz="1200">
+                <a:solidFill>
+                  <a:srgbClr val="8B949E"/>
+                </a:solidFill>
+                <a:latin typeface="Consolas"/>
+              </a:defRPr>
+            </a:pPr>
+            <a:r>
+              <a:t>10</a:t>
+            </a:r>
+          </a:p>
+        </p:txBody>
+      </p:sp>
     </p:spTree>
   </p:cSld>
   <p:clrMapOvr>
@@ -4198,6 +4270,42 @@
           </a:p>
         </p:txBody>
       </p:sp>
+      <p:sp>
+        <p:nvSpPr>
+          <p:cNvPr id="5" name="TextBox 4"/>
+          <p:cNvSpPr txBox="1"/>
+          <p:nvPr/>
+        </p:nvSpPr>
+        <p:spPr>
+          <a:xfrm>
+            <a:off x="7772400" y="6309360"/>
+            <a:ext cx="914400" cy="365760"/>
+          </a:xfrm>
+          <a:prstGeom prst="rect">
+            <a:avLst/>
+          </a:prstGeom>
+          <a:noFill/>
+        </p:spPr>
+        <p:txBody>
+          <a:bodyPr wrap="none">
+            <a:spAutoFit/>
+          </a:bodyPr>
+          <a:lstStyle/>
+          <a:p>
+            <a:pPr algn="r">
+              <a:defRPr sz="1200">
+                <a:solidFill>
+                  <a:srgbClr val="8B949E"/>
+                </a:solidFill>
+                <a:latin typeface="Consolas"/>
+              </a:defRPr>
+            </a:pPr>
+            <a:r>
+              <a:t>1</a:t>
+            </a:r>
+          </a:p>
+        </p:txBody>
+      </p:sp>
     </p:spTree>
   </p:cSld>
   <p:clrMapOvr>
@@ -4505,6 +4613,42 @@
           </a:p>
         </p:txBody>
       </p:sp>
+      <p:sp>
+        <p:nvSpPr>
+          <p:cNvPr id="5" name="TextBox 4"/>
+          <p:cNvSpPr txBox="1"/>
+          <p:nvPr/>
+        </p:nvSpPr>
+        <p:spPr>
+          <a:xfrm>
+            <a:off x="7772400" y="6309360"/>
+            <a:ext cx="914400" cy="365760"/>
+          </a:xfrm>
+          <a:prstGeom prst="rect">
+            <a:avLst/>
+          </a:prstGeom>
+          <a:noFill/>
+        </p:spPr>
+        <p:txBody>
+          <a:bodyPr wrap="none">
+            <a:spAutoFit/>
+          </a:bodyPr>
+          <a:lstStyle/>
+          <a:p>
+            <a:pPr algn="r">
+              <a:defRPr sz="1200">
+                <a:solidFill>
+                  <a:srgbClr val="8B949E"/>
+                </a:solidFill>
+                <a:latin typeface="Consolas"/>
+              </a:defRPr>
+            </a:pPr>
+            <a:r>
+              <a:t>2</a:t>
+            </a:r>
+          </a:p>
+        </p:txBody>
+      </p:sp>
     </p:spTree>
   </p:cSld>
   <p:clrMapOvr>
@@ -4828,6 +4972,42 @@
           </a:p>
         </p:txBody>
       </p:sp>
+      <p:sp>
+        <p:nvSpPr>
+          <p:cNvPr id="5" name="TextBox 4"/>
+          <p:cNvSpPr txBox="1"/>
+          <p:nvPr/>
+        </p:nvSpPr>
+        <p:spPr>
+          <a:xfrm>
+            <a:off x="7772400" y="6309360"/>
+            <a:ext cx="914400" cy="365760"/>
+          </a:xfrm>
+          <a:prstGeom prst="rect">
+            <a:avLst/>
+          </a:prstGeom>
+          <a:noFill/>
+        </p:spPr>
+        <p:txBody>
+          <a:bodyPr wrap="none">
+            <a:spAutoFit/>
+          </a:bodyPr>
+          <a:lstStyle/>
+          <a:p>
+            <a:pPr algn="r">
+              <a:defRPr sz="1200">
+                <a:solidFill>
+                  <a:srgbClr val="8B949E"/>
+                </a:solidFill>
+                <a:latin typeface="Consolas"/>
+              </a:defRPr>
+            </a:pPr>
+            <a:r>
+              <a:t>3</a:t>
+            </a:r>
+          </a:p>
+        </p:txBody>
+      </p:sp>
     </p:spTree>
   </p:cSld>
   <p:clrMapOvr>
@@ -5164,6 +5344,42 @@
           </a:p>
         </p:txBody>
       </p:sp>
+      <p:sp>
+        <p:nvSpPr>
+          <p:cNvPr id="5" name="TextBox 4"/>
+          <p:cNvSpPr txBox="1"/>
+          <p:nvPr/>
+        </p:nvSpPr>
+        <p:spPr>
+          <a:xfrm>
+            <a:off x="7772400" y="6309360"/>
+            <a:ext cx="914400" cy="365760"/>
+          </a:xfrm>
+          <a:prstGeom prst="rect">
+            <a:avLst/>
+          </a:prstGeom>
+          <a:noFill/>
+        </p:spPr>
+        <p:txBody>
+          <a:bodyPr wrap="none">
+            <a:spAutoFit/>
+          </a:bodyPr>
+          <a:lstStyle/>
+          <a:p>
+            <a:pPr algn="r">
+              <a:defRPr sz="1200">
+                <a:solidFill>
+                  <a:srgbClr val="8B949E"/>
+                </a:solidFill>
+                <a:latin typeface="Consolas"/>
+              </a:defRPr>
+            </a:pPr>
+            <a:r>
+              <a:t>4</a:t>
+            </a:r>
+          </a:p>
+        </p:txBody>
+      </p:sp>
     </p:spTree>
   </p:cSld>
   <p:clrMapOvr>
@@ -5484,6 +5700,42 @@
           </a:p>
         </p:txBody>
       </p:sp>
+      <p:sp>
+        <p:nvSpPr>
+          <p:cNvPr id="5" name="TextBox 4"/>
+          <p:cNvSpPr txBox="1"/>
+          <p:nvPr/>
+        </p:nvSpPr>
+        <p:spPr>
+          <a:xfrm>
+            <a:off x="7772400" y="6309360"/>
+            <a:ext cx="914400" cy="365760"/>
+          </a:xfrm>
+          <a:prstGeom prst="rect">
+            <a:avLst/>
+          </a:prstGeom>
+          <a:noFill/>
+        </p:spPr>
+        <p:txBody>
+          <a:bodyPr wrap="none">
+            <a:spAutoFit/>
+          </a:bodyPr>
+          <a:lstStyle/>
+          <a:p>
+            <a:pPr algn="r">
+              <a:defRPr sz="1200">
+                <a:solidFill>
+                  <a:srgbClr val="8B949E"/>
+                </a:solidFill>
+                <a:latin typeface="Consolas"/>
+              </a:defRPr>
+            </a:pPr>
+            <a:r>
+              <a:t>5</a:t>
+            </a:r>
+          </a:p>
+        </p:txBody>
+      </p:sp>
     </p:spTree>
   </p:cSld>
   <p:clrMapOvr>
@@ -5836,6 +6088,42 @@
           </a:p>
         </p:txBody>
       </p:sp>
+      <p:sp>
+        <p:nvSpPr>
+          <p:cNvPr id="5" name="TextBox 4"/>
+          <p:cNvSpPr txBox="1"/>
+          <p:nvPr/>
+        </p:nvSpPr>
+        <p:spPr>
+          <a:xfrm>
+            <a:off x="7772400" y="6309360"/>
+            <a:ext cx="914400" cy="365760"/>
+          </a:xfrm>
+          <a:prstGeom prst="rect">
+            <a:avLst/>
+          </a:prstGeom>
+          <a:noFill/>
+        </p:spPr>
+        <p:txBody>
+          <a:bodyPr wrap="none">
+            <a:spAutoFit/>
+          </a:bodyPr>
+          <a:lstStyle/>
+          <a:p>
+            <a:pPr algn="r">
+              <a:defRPr sz="1200">
+                <a:solidFill>
+                  <a:srgbClr val="8B949E"/>
+                </a:solidFill>
+                <a:latin typeface="Consolas"/>
+              </a:defRPr>
+            </a:pPr>
+            <a:r>
+              <a:t>6</a:t>
+            </a:r>
+          </a:p>
+        </p:txBody>
+      </p:sp>
     </p:spTree>
   </p:cSld>
   <p:clrMapOvr>
@@ -6172,6 +6460,42 @@
           </a:p>
         </p:txBody>
       </p:sp>
+      <p:sp>
+        <p:nvSpPr>
+          <p:cNvPr id="5" name="TextBox 4"/>
+          <p:cNvSpPr txBox="1"/>
+          <p:nvPr/>
+        </p:nvSpPr>
+        <p:spPr>
+          <a:xfrm>
+            <a:off x="7772400" y="6309360"/>
+            <a:ext cx="914400" cy="365760"/>
+          </a:xfrm>
+          <a:prstGeom prst="rect">
+            <a:avLst/>
+          </a:prstGeom>
+          <a:noFill/>
+        </p:spPr>
+        <p:txBody>
+          <a:bodyPr wrap="none">
+            <a:spAutoFit/>
+          </a:bodyPr>
+          <a:lstStyle/>
+          <a:p>
+            <a:pPr algn="r">
+              <a:defRPr sz="1200">
+                <a:solidFill>
+                  <a:srgbClr val="8B949E"/>
+                </a:solidFill>
+                <a:latin typeface="Consolas"/>
+              </a:defRPr>
+            </a:pPr>
+            <a:r>
+              <a:t>7</a:t>
+            </a:r>
+          </a:p>
+        </p:txBody>
+      </p:sp>
     </p:spTree>
   </p:cSld>
   <p:clrMapOvr>
@@ -6520,6 +6844,42 @@
             </a:pPr>
             <a:r>
               <a:t>Manuel Ott · Hofer Lab · 2025-11-19</a:t>
+            </a:r>
+          </a:p>
+        </p:txBody>
+      </p:sp>
+      <p:sp>
+        <p:nvSpPr>
+          <p:cNvPr id="5" name="TextBox 4"/>
+          <p:cNvSpPr txBox="1"/>
+          <p:nvPr/>
+        </p:nvSpPr>
+        <p:spPr>
+          <a:xfrm>
+            <a:off x="7772400" y="6309360"/>
+            <a:ext cx="914400" cy="365760"/>
+          </a:xfrm>
+          <a:prstGeom prst="rect">
+            <a:avLst/>
+          </a:prstGeom>
+          <a:noFill/>
+        </p:spPr>
+        <p:txBody>
+          <a:bodyPr wrap="none">
+            <a:spAutoFit/>
+          </a:bodyPr>
+          <a:lstStyle/>
+          <a:p>
+            <a:pPr algn="r">
+              <a:defRPr sz="1200">
+                <a:solidFill>
+                  <a:srgbClr val="8B949E"/>
+                </a:solidFill>
+                <a:latin typeface="Consolas"/>
+              </a:defRPr>
+            </a:pPr>
+            <a:r>
+              <a:t>8</a:t>
             </a:r>
           </a:p>
         </p:txBody>

</xml_diff>